<commit_message>
fix a pinout error
</commit_message>
<xml_diff>
--- a/Research/Chip_comparison.pptx
+++ b/Research/Chip_comparison.pptx
@@ -115,7 +115,7 @@
   </p:defaultTextStyle>
   <p:extLst>
     <p:ext uri="{EFAFB233-063F-42B5-8137-9DF3F51BA10A}">
-      <p15:sldGuideLst xmlns:p15="http://schemas.microsoft.com/office/powerpoint/2012/main" xmlns="">
+      <p15:sldGuideLst xmlns="" xmlns:p15="http://schemas.microsoft.com/office/powerpoint/2012/main">
         <p15:guide id="1" orient="horz" pos="2160">
           <p15:clr>
             <a:srgbClr val="A4A3A4"/>
@@ -264,7 +264,7 @@
             <a:fld id="{4EA84CA3-116E-4ABF-8AA6-EBE32C84C16F}" type="datetimeFigureOut">
               <a:rPr lang="fr-FR" smtClean="0"/>
               <a:pPr/>
-              <a:t>04/09/2026</a:t>
+              <a:t>06/09/2026</a:t>
             </a:fld>
             <a:endParaRPr lang="fr-FR"/>
           </a:p>
@@ -316,7 +316,7 @@
     </p:spTree>
     <p:extLst>
       <p:ext uri="{BB962C8B-B14F-4D97-AF65-F5344CB8AC3E}">
-        <p14:creationId xmlns:p14="http://schemas.microsoft.com/office/powerpoint/2010/main" xmlns="" val="2003778223"/>
+        <p14:creationId xmlns="" xmlns:p14="http://schemas.microsoft.com/office/powerpoint/2010/main" val="2003778223"/>
       </p:ext>
     </p:extLst>
   </p:cSld>
@@ -436,7 +436,7 @@
             <a:fld id="{4EA84CA3-116E-4ABF-8AA6-EBE32C84C16F}" type="datetimeFigureOut">
               <a:rPr lang="fr-FR" smtClean="0"/>
               <a:pPr/>
-              <a:t>04/09/2026</a:t>
+              <a:t>06/09/2026</a:t>
             </a:fld>
             <a:endParaRPr lang="fr-FR"/>
           </a:p>
@@ -488,7 +488,7 @@
     </p:spTree>
     <p:extLst>
       <p:ext uri="{BB962C8B-B14F-4D97-AF65-F5344CB8AC3E}">
-        <p14:creationId xmlns:p14="http://schemas.microsoft.com/office/powerpoint/2010/main" xmlns="" val="3709322164"/>
+        <p14:creationId xmlns="" xmlns:p14="http://schemas.microsoft.com/office/powerpoint/2010/main" val="3709322164"/>
       </p:ext>
     </p:extLst>
   </p:cSld>
@@ -618,7 +618,7 @@
             <a:fld id="{4EA84CA3-116E-4ABF-8AA6-EBE32C84C16F}" type="datetimeFigureOut">
               <a:rPr lang="fr-FR" smtClean="0"/>
               <a:pPr/>
-              <a:t>04/09/2026</a:t>
+              <a:t>06/09/2026</a:t>
             </a:fld>
             <a:endParaRPr lang="fr-FR"/>
           </a:p>
@@ -670,7 +670,7 @@
     </p:spTree>
     <p:extLst>
       <p:ext uri="{BB962C8B-B14F-4D97-AF65-F5344CB8AC3E}">
-        <p14:creationId xmlns:p14="http://schemas.microsoft.com/office/powerpoint/2010/main" xmlns="" val="1419434073"/>
+        <p14:creationId xmlns="" xmlns:p14="http://schemas.microsoft.com/office/powerpoint/2010/main" val="1419434073"/>
       </p:ext>
     </p:extLst>
   </p:cSld>
@@ -790,7 +790,7 @@
             <a:fld id="{4EA84CA3-116E-4ABF-8AA6-EBE32C84C16F}" type="datetimeFigureOut">
               <a:rPr lang="fr-FR" smtClean="0"/>
               <a:pPr/>
-              <a:t>04/09/2026</a:t>
+              <a:t>06/09/2026</a:t>
             </a:fld>
             <a:endParaRPr lang="fr-FR"/>
           </a:p>
@@ -842,7 +842,7 @@
     </p:spTree>
     <p:extLst>
       <p:ext uri="{BB962C8B-B14F-4D97-AF65-F5344CB8AC3E}">
-        <p14:creationId xmlns:p14="http://schemas.microsoft.com/office/powerpoint/2010/main" xmlns="" val="1102157496"/>
+        <p14:creationId xmlns="" xmlns:p14="http://schemas.microsoft.com/office/powerpoint/2010/main" val="1102157496"/>
       </p:ext>
     </p:extLst>
   </p:cSld>
@@ -1038,7 +1038,7 @@
             <a:fld id="{4EA84CA3-116E-4ABF-8AA6-EBE32C84C16F}" type="datetimeFigureOut">
               <a:rPr lang="fr-FR" smtClean="0"/>
               <a:pPr/>
-              <a:t>04/09/2026</a:t>
+              <a:t>06/09/2026</a:t>
             </a:fld>
             <a:endParaRPr lang="fr-FR"/>
           </a:p>
@@ -1090,7 +1090,7 @@
     </p:spTree>
     <p:extLst>
       <p:ext uri="{BB962C8B-B14F-4D97-AF65-F5344CB8AC3E}">
-        <p14:creationId xmlns:p14="http://schemas.microsoft.com/office/powerpoint/2010/main" xmlns="" val="660080195"/>
+        <p14:creationId xmlns="" xmlns:p14="http://schemas.microsoft.com/office/powerpoint/2010/main" val="660080195"/>
       </p:ext>
     </p:extLst>
   </p:cSld>
@@ -1272,7 +1272,7 @@
             <a:fld id="{4EA84CA3-116E-4ABF-8AA6-EBE32C84C16F}" type="datetimeFigureOut">
               <a:rPr lang="fr-FR" smtClean="0"/>
               <a:pPr/>
-              <a:t>04/09/2026</a:t>
+              <a:t>06/09/2026</a:t>
             </a:fld>
             <a:endParaRPr lang="fr-FR"/>
           </a:p>
@@ -1324,7 +1324,7 @@
     </p:spTree>
     <p:extLst>
       <p:ext uri="{BB962C8B-B14F-4D97-AF65-F5344CB8AC3E}">
-        <p14:creationId xmlns:p14="http://schemas.microsoft.com/office/powerpoint/2010/main" xmlns="" val="2283449542"/>
+        <p14:creationId xmlns="" xmlns:p14="http://schemas.microsoft.com/office/powerpoint/2010/main" val="2283449542"/>
       </p:ext>
     </p:extLst>
   </p:cSld>
@@ -1641,7 +1641,7 @@
             <a:fld id="{4EA84CA3-116E-4ABF-8AA6-EBE32C84C16F}" type="datetimeFigureOut">
               <a:rPr lang="fr-FR" smtClean="0"/>
               <a:pPr/>
-              <a:t>04/09/2026</a:t>
+              <a:t>06/09/2026</a:t>
             </a:fld>
             <a:endParaRPr lang="fr-FR"/>
           </a:p>
@@ -1693,7 +1693,7 @@
     </p:spTree>
     <p:extLst>
       <p:ext uri="{BB962C8B-B14F-4D97-AF65-F5344CB8AC3E}">
-        <p14:creationId xmlns:p14="http://schemas.microsoft.com/office/powerpoint/2010/main" xmlns="" val="2663865323"/>
+        <p14:creationId xmlns="" xmlns:p14="http://schemas.microsoft.com/office/powerpoint/2010/main" val="2663865323"/>
       </p:ext>
     </p:extLst>
   </p:cSld>
@@ -1761,7 +1761,7 @@
             <a:fld id="{4EA84CA3-116E-4ABF-8AA6-EBE32C84C16F}" type="datetimeFigureOut">
               <a:rPr lang="fr-FR" smtClean="0"/>
               <a:pPr/>
-              <a:t>04/09/2026</a:t>
+              <a:t>06/09/2026</a:t>
             </a:fld>
             <a:endParaRPr lang="fr-FR"/>
           </a:p>
@@ -1813,7 +1813,7 @@
     </p:spTree>
     <p:extLst>
       <p:ext uri="{BB962C8B-B14F-4D97-AF65-F5344CB8AC3E}">
-        <p14:creationId xmlns:p14="http://schemas.microsoft.com/office/powerpoint/2010/main" xmlns="" val="376323583"/>
+        <p14:creationId xmlns="" xmlns:p14="http://schemas.microsoft.com/office/powerpoint/2010/main" val="376323583"/>
       </p:ext>
     </p:extLst>
   </p:cSld>
@@ -1858,7 +1858,7 @@
             <a:fld id="{4EA84CA3-116E-4ABF-8AA6-EBE32C84C16F}" type="datetimeFigureOut">
               <a:rPr lang="fr-FR" smtClean="0"/>
               <a:pPr/>
-              <a:t>04/09/2026</a:t>
+              <a:t>06/09/2026</a:t>
             </a:fld>
             <a:endParaRPr lang="fr-FR"/>
           </a:p>
@@ -1910,7 +1910,7 @@
     </p:spTree>
     <p:extLst>
       <p:ext uri="{BB962C8B-B14F-4D97-AF65-F5344CB8AC3E}">
-        <p14:creationId xmlns:p14="http://schemas.microsoft.com/office/powerpoint/2010/main" xmlns="" val="3989902220"/>
+        <p14:creationId xmlns="" xmlns:p14="http://schemas.microsoft.com/office/powerpoint/2010/main" val="3989902220"/>
       </p:ext>
     </p:extLst>
   </p:cSld>
@@ -2137,7 +2137,7 @@
             <a:fld id="{4EA84CA3-116E-4ABF-8AA6-EBE32C84C16F}" type="datetimeFigureOut">
               <a:rPr lang="fr-FR" smtClean="0"/>
               <a:pPr/>
-              <a:t>04/09/2026</a:t>
+              <a:t>06/09/2026</a:t>
             </a:fld>
             <a:endParaRPr lang="fr-FR"/>
           </a:p>
@@ -2189,7 +2189,7 @@
     </p:spTree>
     <p:extLst>
       <p:ext uri="{BB962C8B-B14F-4D97-AF65-F5344CB8AC3E}">
-        <p14:creationId xmlns:p14="http://schemas.microsoft.com/office/powerpoint/2010/main" xmlns="" val="1997102884"/>
+        <p14:creationId xmlns="" xmlns:p14="http://schemas.microsoft.com/office/powerpoint/2010/main" val="1997102884"/>
       </p:ext>
     </p:extLst>
   </p:cSld>
@@ -2392,7 +2392,7 @@
             <a:fld id="{4EA84CA3-116E-4ABF-8AA6-EBE32C84C16F}" type="datetimeFigureOut">
               <a:rPr lang="fr-FR" smtClean="0"/>
               <a:pPr/>
-              <a:t>04/09/2026</a:t>
+              <a:t>06/09/2026</a:t>
             </a:fld>
             <a:endParaRPr lang="fr-FR"/>
           </a:p>
@@ -2444,7 +2444,7 @@
     </p:spTree>
     <p:extLst>
       <p:ext uri="{BB962C8B-B14F-4D97-AF65-F5344CB8AC3E}">
-        <p14:creationId xmlns:p14="http://schemas.microsoft.com/office/powerpoint/2010/main" xmlns="" val="3738991770"/>
+        <p14:creationId xmlns="" xmlns:p14="http://schemas.microsoft.com/office/powerpoint/2010/main" val="3738991770"/>
       </p:ext>
     </p:extLst>
   </p:cSld>
@@ -2607,7 +2607,7 @@
             <a:fld id="{4EA84CA3-116E-4ABF-8AA6-EBE32C84C16F}" type="datetimeFigureOut">
               <a:rPr lang="fr-FR" smtClean="0"/>
               <a:pPr/>
-              <a:t>04/09/2026</a:t>
+              <a:t>06/09/2026</a:t>
             </a:fld>
             <a:endParaRPr lang="fr-FR"/>
           </a:p>
@@ -2695,7 +2695,7 @@
     </p:spTree>
     <p:extLst>
       <p:ext uri="{BB962C8B-B14F-4D97-AF65-F5344CB8AC3E}">
-        <p14:creationId xmlns:p14="http://schemas.microsoft.com/office/powerpoint/2010/main" xmlns="" val="4265157320"/>
+        <p14:creationId xmlns="" xmlns:p14="http://schemas.microsoft.com/office/powerpoint/2010/main" val="4265157320"/>
       </p:ext>
     </p:extLst>
   </p:cSld>
@@ -3798,7 +3798,7 @@
     </p:spTree>
     <p:extLst>
       <p:ext uri="{BB962C8B-B14F-4D97-AF65-F5344CB8AC3E}">
-        <p14:creationId xmlns:p14="http://schemas.microsoft.com/office/powerpoint/2010/main" xmlns="" val="3760226372"/>
+        <p14:creationId xmlns="" xmlns:p14="http://schemas.microsoft.com/office/powerpoint/2010/main" val="3760226372"/>
       </p:ext>
     </p:extLst>
   </p:cSld>
@@ -4730,8 +4730,13 @@
                   <a:srgbClr val="FF0000"/>
                 </a:solidFill>
               </a:rPr>
-              <a:t>D6</a:t>
-            </a:r>
+              <a:t>D16</a:t>
+            </a:r>
+            <a:endParaRPr lang="fr-FR" dirty="0" smtClean="0">
+              <a:solidFill>
+                <a:srgbClr val="FF0000"/>
+              </a:solidFill>
+            </a:endParaRPr>
           </a:p>
         </p:txBody>
       </p:sp>
@@ -6320,7 +6325,7 @@
     </p:spTree>
     <p:extLst>
       <p:ext uri="{BB962C8B-B14F-4D97-AF65-F5344CB8AC3E}">
-        <p14:creationId xmlns:p14="http://schemas.microsoft.com/office/powerpoint/2010/main" xmlns="" val="3760226372"/>
+        <p14:creationId xmlns="" xmlns:p14="http://schemas.microsoft.com/office/powerpoint/2010/main" val="3760226372"/>
       </p:ext>
     </p:extLst>
   </p:cSld>
@@ -6511,7 +6516,7 @@
     </p:spTree>
     <p:extLst>
       <p:ext uri="{BB962C8B-B14F-4D97-AF65-F5344CB8AC3E}">
-        <p14:creationId xmlns:p14="http://schemas.microsoft.com/office/powerpoint/2010/main" xmlns="" val="3452558061"/>
+        <p14:creationId xmlns="" xmlns:p14="http://schemas.microsoft.com/office/powerpoint/2010/main" val="3452558061"/>
       </p:ext>
     </p:extLst>
   </p:cSld>
@@ -6665,7 +6670,7 @@
     </p:spTree>
     <p:extLst>
       <p:ext uri="{BB962C8B-B14F-4D97-AF65-F5344CB8AC3E}">
-        <p14:creationId xmlns:p14="http://schemas.microsoft.com/office/powerpoint/2010/main" xmlns="" val="141957672"/>
+        <p14:creationId xmlns="" xmlns:p14="http://schemas.microsoft.com/office/powerpoint/2010/main" val="141957672"/>
       </p:ext>
     </p:extLst>
   </p:cSld>
@@ -6950,7 +6955,7 @@
     </p:spTree>
     <p:extLst>
       <p:ext uri="{BB962C8B-B14F-4D97-AF65-F5344CB8AC3E}">
-        <p14:creationId xmlns:p14="http://schemas.microsoft.com/office/powerpoint/2010/main" xmlns="" val="141957672"/>
+        <p14:creationId xmlns="" xmlns:p14="http://schemas.microsoft.com/office/powerpoint/2010/main" val="141957672"/>
       </p:ext>
     </p:extLst>
   </p:cSld>
@@ -7430,7 +7435,7 @@
   <a:extraClrSchemeLst/>
   <a:extLst>
     <a:ext uri="{05A4C25C-085E-4340-85A3-A5531E510DB2}">
-      <thm15:themeFamily xmlns:thm15="http://schemas.microsoft.com/office/thememl/2012/main" xmlns="" name="Office Theme" id="{62F939B6-93AF-4DB8-9C6B-D6C7DFDC589F}" vid="{4A3C46E8-61CC-4603-A589-7422A47A8E4A}"/>
+      <thm15:themeFamily xmlns="" xmlns:thm15="http://schemas.microsoft.com/office/thememl/2012/main" name="Office Theme" id="{62F939B6-93AF-4DB8-9C6B-D6C7DFDC589F}" vid="{4A3C46E8-61CC-4603-A589-7422A47A8E4A}"/>
     </a:ext>
   </a:extLst>
 </a:theme>

</xml_diff>